<commit_message>
Fix repo links and make zone-matching text match the code
- Point README badge, report header and slides at tgup0010-bot/MMA3001_FINAL
- Report Section 6, README and slide 5 now describe the lagged-correlation
  method in occupancy.sensor_matching, with its actual results; the weekend
  single-zone numbers had no code behind them
- Restore occupancy.rooms (sensor_matching_analysis.py failed to import it)
- Add a reproducible chart script for the sensor-matching results
- Restore preprocessing/rooms/evaluation tests; test regression metrics
  instead of the unused classification metric (54 tests)
- Regenerate API docs, test report and report .docx
</commit_message>
<xml_diff>
--- a/docs/MMA3001_Presentation.pptx
+++ b/docs/MMA3001_Presentation.pptx
@@ -7051,7 +7051,7 @@
                   <a:srgbClr val="AAC8FF"/>
                 </a:solidFill>
               </a:rPr>
-              <a:t>github.com/tgup0010-bot/MMA_Final  ·  All numbers reproducible from the scripts; results in reports/</a:t>
+              <a:t>github.com/tgup0010-bot/MMA3001_FINAL  ·  All numbers reproducible from the scripts; results in reports/</a:t>
             </a:r>
           </a:p>
         </p:txBody>
@@ -9731,7 +9731,7 @@
         <p:spPr>
           <a:xfrm>
             <a:off x="0" y="0"/>
-            <a:ext cx="9144000" cy="1005840"/>
+            <a:ext cx="12188952" cy="1340784"/>
           </a:xfrm>
           <a:prstGeom prst="rect">
             <a:avLst/>
@@ -9773,8 +9773,8 @@
         </p:nvSpPr>
         <p:spPr>
           <a:xfrm>
-            <a:off x="182880" y="91440"/>
-            <a:ext cx="8686800" cy="822960"/>
+            <a:off x="243779" y="121889"/>
+            <a:ext cx="11579504" cy="1097005"/>
           </a:xfrm>
           <a:prstGeom prst="rect">
             <a:avLst/>
@@ -9789,12 +9789,12 @@
           <a:p>
             <a:pPr algn="l"/>
             <a:r>
-              <a:rPr sz="2200" b="1">
+              <a:rPr sz="2950" b="1">
                 <a:solidFill>
                   <a:srgbClr val="FFFFFF"/>
                 </a:solidFill>
               </a:rPr>
-              <a:t>Zone Matching — Can We Link Sensor to a Room?</a:t>
+              <a:t>Sensor Matching — Can We Link Sensor to a Room?</a:t>
             </a:r>
           </a:p>
         </p:txBody>
@@ -9807,8 +9807,8 @@
         </p:nvSpPr>
         <p:spPr>
           <a:xfrm>
-            <a:off x="182880" y="685800"/>
-            <a:ext cx="8686800" cy="320040"/>
+            <a:off x="243779" y="914171"/>
+            <a:ext cx="11579504" cy="426613"/>
           </a:xfrm>
           <a:prstGeom prst="rect">
             <a:avLst/>
@@ -9823,12 +9823,12 @@
           <a:p>
             <a:pPr algn="l"/>
             <a:r>
-              <a:rPr sz="1150" b="0">
+              <a:rPr sz="1550" b="0">
                 <a:solidFill>
                   <a:srgbClr val="C0D8F5"/>
                 </a:solidFill>
               </a:rPr>
-              <a:t>Keena's weekend spike method · 9 million occupancy rows · 29,039 CO2 readings</a:t>
+              <a:t>Keenan's suggestion: look for the link in the data  ·  lagged correlation  ·  5 zones × 5 sensors  ·  CO2, temperature, humidity</a:t>
             </a:r>
           </a:p>
         </p:txBody>
@@ -9842,15 +9842,15 @@
           <p:nvPr/>
         </p:nvPicPr>
         <p:blipFill>
-          <a:blip r:embed="rId2"/>
+          <a:blip r:embed="rId3"/>
           <a:stretch>
             <a:fillRect/>
           </a:stretch>
         </p:blipFill>
         <p:spPr>
           <a:xfrm>
-            <a:off x="182880" y="1051560"/>
-            <a:ext cx="7132320" cy="3017520"/>
+            <a:off x="243779" y="1401729"/>
+            <a:ext cx="9108089" cy="4022354"/>
           </a:xfrm>
           <a:prstGeom prst="rect">
             <a:avLst/>
@@ -9865,8 +9865,8 @@
         </p:nvSpPr>
         <p:spPr>
           <a:xfrm>
-            <a:off x="7406640" y="1051560"/>
-            <a:ext cx="1600200" cy="1371600"/>
+            <a:off x="9873051" y="1401729"/>
+            <a:ext cx="2133066" cy="1828342"/>
           </a:xfrm>
           <a:prstGeom prst="rect">
             <a:avLst/>
@@ -9908,8 +9908,8 @@
         </p:nvSpPr>
         <p:spPr>
           <a:xfrm>
-            <a:off x="7452360" y="1078992"/>
-            <a:ext cx="1508760" cy="274320"/>
+            <a:off x="9933995" y="1438296"/>
+            <a:ext cx="2011177" cy="365668"/>
           </a:xfrm>
           <a:prstGeom prst="rect">
             <a:avLst/>
@@ -9924,7 +9924,7 @@
           <a:p>
             <a:pPr algn="l"/>
             <a:r>
-              <a:rPr sz="900" b="1">
+              <a:rPr sz="1200" b="1">
                 <a:solidFill>
                   <a:srgbClr val="0B0B0B"/>
                 </a:solidFill>
@@ -9942,8 +9942,8 @@
         </p:nvSpPr>
         <p:spPr>
           <a:xfrm>
-            <a:off x="7452360" y="1353312"/>
-            <a:ext cx="1508760" cy="1005840"/>
+            <a:off x="9933995" y="1803964"/>
+            <a:ext cx="2011177" cy="1340784"/>
           </a:xfrm>
           <a:prstGeom prst="rect">
             <a:avLst/>
@@ -9958,15 +9958,39 @@
           <a:p>
             <a:pPr algn="l"/>
             <a:r>
-              <a:rPr sz="850" b="0">
+              <a:rPr sz="1150" b="0">
                 <a:solidFill>
                   <a:srgbClr val="52514E"/>
                 </a:solidFill>
               </a:rPr>
-              <a:t>1. Filter to weekends
-2. Find bins with 1 zone active
-3. Check CO2 spike
-4. Expected: +50–200 ppm</a:t>
+              <a:t>1. Resample zones and sensors to 15 min</a:t>
+            </a:r>
+            <a:br/>
+            <a:r>
+              <a:rPr sz="1150" b="0">
+                <a:solidFill>
+                  <a:srgbClr val="52514E"/>
+                </a:solidFill>
+              </a:rPr>
+              <a:t>2. Use change per bin, not level</a:t>
+            </a:r>
+            <a:br/>
+            <a:r>
+              <a:rPr sz="1150" b="0">
+                <a:solidFill>
+                  <a:srgbClr val="52514E"/>
+                </a:solidFill>
+              </a:rPr>
+              <a:t>3. Correlate with occupancy at lags up to ±1 h</a:t>
+            </a:r>
+            <a:br/>
+            <a:r>
+              <a:rPr sz="1150" b="0">
+                <a:solidFill>
+                  <a:srgbClr val="52514E"/>
+                </a:solidFill>
+              </a:rPr>
+              <a:t>4. Keep strongest |r| per pair</a:t>
             </a:r>
           </a:p>
         </p:txBody>
@@ -9979,8 +10003,8 @@
         </p:nvSpPr>
         <p:spPr>
           <a:xfrm>
-            <a:off x="182880" y="4160520"/>
-            <a:ext cx="8686800" cy="685800"/>
+            <a:off x="243779" y="5545973"/>
+            <a:ext cx="11579504" cy="914171"/>
           </a:xfrm>
           <a:prstGeom prst="rect">
             <a:avLst/>
@@ -10022,8 +10046,8 @@
         </p:nvSpPr>
         <p:spPr>
           <a:xfrm>
-            <a:off x="274320" y="4206240"/>
-            <a:ext cx="8412480" cy="594360"/>
+            <a:off x="365668" y="5606917"/>
+            <a:ext cx="11213835" cy="792281"/>
           </a:xfrm>
           <a:prstGeom prst="rect">
             <a:avLst/>
@@ -10038,12 +10062,12 @@
           <a:p>
             <a:pPr algn="l"/>
             <a:r>
-              <a:rPr sz="1150" b="1">
+              <a:rPr sz="1550" b="1">
                 <a:solidFill>
                   <a:srgbClr val="E34948"/>
                 </a:solidFill>
               </a:rPr>
-              <a:t>✗  No zone produced a meaningful CO2 spike (largest: +6.2 ppm vs expected 50–200 ppm)  ·  All correlations are negative  ·  Sensor 0326 is not in any monitored room</a:t>
+              <a:t>✗  CO2: |r| ≤ 0.03 for sensor 0326 against every zone (≤ 0.06 for any sensor)  ·  Temperature up to r = 0.27, but it rises 45–60 min before occupancy → building-wide HVAC, not a shared room</a:t>
             </a:r>
           </a:p>
         </p:txBody>

</xml_diff>